<commit_message>
Suíte enxuta: 15 funcionais, 4 estruturais e 6 de mutação
O recorte passa a se concentrar na reserva (reserve, cal_cost e auxiliares);
a consulta de disponibilidade (RF-04) vira requisito secundário, com casos
complementares ao lado dos do cancelamento. Classes de equivalência
reorganizadas (22 no recorte, um caso por classe inválida, limites
embutidos) e casos renumerados de CT-001 a CT-025 (complementares CT-101+).

Todas as etapas reexecutadas: funcional 15 casos (9 defeitos), estrutural
19 casos (63/63 comandos, 33/34 desvios; DEF-15), corrigida 19/19 (100%),
mutação 127/141 -> 134/141 (7 equivalentes). Evidências, relatório e
apresentações regenerados.
</commit_message>
<xml_diff>
--- a/docs/apresentacao-2-slides.pptx
+++ b/docs/apresentacao-2-slides.pptx
@@ -164,16 +164,16 @@
               <c:strCache>
                 <c:ptCount val="4"/>
                 <c:pt idx="0">
-                  <c:v>Funcional (50)</c:v>
+                  <c:v>Funcional (15)</c:v>
                 </c:pt>
                 <c:pt idx="1">
-                  <c:v>Estrutural (57)</c:v>
+                  <c:v>Estrutural (19)</c:v>
                 </c:pt>
                 <c:pt idx="2">
-                  <c:v>Correção (57)</c:v>
+                  <c:v>Correção (19)</c:v>
                 </c:pt>
                 <c:pt idx="3">
-                  <c:v>Mutação (60)</c:v>
+                  <c:v>Mutação (25)</c:v>
                 </c:pt>
               </c:strCache>
             </c:strRef>
@@ -185,7 +185,7 @@
                 <c:formatCode>General</c:formatCode>
                 <c:ptCount val="4"/>
                 <c:pt idx="0">
-                  <c:v>0.9129999999999999</c:v>
+                  <c:v>0.9520000000000001</c:v>
                 </c:pt>
                 <c:pt idx="1">
                   <c:v>1.0</c:v>
@@ -247,16 +247,16 @@
               <c:strCache>
                 <c:ptCount val="4"/>
                 <c:pt idx="0">
-                  <c:v>Funcional (50)</c:v>
+                  <c:v>Funcional (15)</c:v>
                 </c:pt>
                 <c:pt idx="1">
-                  <c:v>Estrutural (57)</c:v>
+                  <c:v>Estrutural (19)</c:v>
                 </c:pt>
                 <c:pt idx="2">
-                  <c:v>Correção (57)</c:v>
+                  <c:v>Correção (19)</c:v>
                 </c:pt>
                 <c:pt idx="3">
-                  <c:v>Mutação (60)</c:v>
+                  <c:v>Mutação (25)</c:v>
                 </c:pt>
               </c:strCache>
             </c:strRef>
@@ -268,10 +268,10 @@
                 <c:formatCode>General</c:formatCode>
                 <c:ptCount val="4"/>
                 <c:pt idx="0">
-                  <c:v>0.84</c:v>
+                  <c:v>0.853</c:v>
                 </c:pt>
                 <c:pt idx="1">
-                  <c:v>0.98</c:v>
+                  <c:v>0.971</c:v>
                 </c:pt>
                 <c:pt idx="2">
                   <c:v>1.0</c:v>
@@ -330,16 +330,16 @@
               <c:strCache>
                 <c:ptCount val="4"/>
                 <c:pt idx="0">
-                  <c:v>Funcional (50)</c:v>
+                  <c:v>Funcional (15)</c:v>
                 </c:pt>
                 <c:pt idx="1">
-                  <c:v>Estrutural (57)</c:v>
+                  <c:v>Estrutural (19)</c:v>
                 </c:pt>
                 <c:pt idx="2">
-                  <c:v>Correção (57)</c:v>
+                  <c:v>Correção (19)</c:v>
                 </c:pt>
                 <c:pt idx="3">
-                  <c:v>Mutação (60)</c:v>
+                  <c:v>Mutação (25)</c:v>
                 </c:pt>
               </c:strCache>
             </c:strRef>
@@ -351,10 +351,10 @@
                 <c:formatCode>General</c:formatCode>
                 <c:ptCount val="4"/>
                 <c:pt idx="2">
-                  <c:v>0.9420000000000001</c:v>
+                  <c:v>0.9009999999999999</c:v>
                 </c:pt>
                 <c:pt idx="3">
-                  <c:v>0.958</c:v>
+                  <c:v>0.95</c:v>
                 </c:pt>
               </c:numCache>
             </c:numRef>
@@ -841,13 +841,13 @@
           <a:p/>
           <a:p>
             <a:r>
-              <a:t>Funcional (40 s): só com o README e a interface, particionei 19 condições em 42 classes e apliquei valor limite (entrada hoje, uma noite, capacidade, estadias adjacentes). Foram 50 casos; no código original 28 falharam e revelaram 12 defeitos.</a:t>
+              <a:t>Funcional (40 s): só com o README e o formulário de reserva, particionei 10 condições em 22 classes: um caso para cada classe inválida, com os limites embutidos (entrada hoje, uma noite, capacidade, estadias adjacentes). Foram 15 casos; no código original 9 falharam e revelaram 9 defeitos.</a:t>
             </a:r>
           </a:p>
           <a:p/>
           <a:p>
             <a:r>
-              <a:t>Estrutural (40 s): medi com coverage.py --branch e defini a meta de 100% dos desvios viáveis. Os ramos que faltavam levaram a 7 casos novos e, lendo o código, a 3 defeitos que a especificação não sugeria: estado global, remoção dentro do laço e um produto cartesiano.</a:t>
+              <a:t>Estrutural (40 s): medi com coverage.py --branch e defini a meta de 100% dos desvios viáveis. Os ramos que faltavam levaram a 4 casos novos e, lendo o laço triplo, a um defeito que a especificação não sugeria: um produto cartesiano entre reservas e vínculos, mascarado pela tautologia.</a:t>
             </a:r>
           </a:p>
           <a:p/>
@@ -859,7 +859,7 @@
           <a:p/>
           <a:p>
             <a:r>
-              <a:t>Mutação (40 s): Cosmic Ray sobre todos os 189 mutantes das funções dos três requisitos. Dos 11 vivos, 3 eram matáveis e ganharam casos; os 8 restantes são equivalentes e estão justificados no relatório.</a:t>
+              <a:t>Mutação (40 s): Cosmic Ray sobre todos os 141 mutantes das funções dos três requisitos. Dos 14 vivos, 7 eram matáveis e ganharam casos; os 7 restantes são equivalentes e estão justificados no relatório.</a:t>
             </a:r>
           </a:p>
           <a:p/>
@@ -935,7 +935,7 @@
           <a:lstStyle/>
           <a:p>
             <a:r>
-              <a:t>Números (30 s): a suíte final tem 60 casos, 100% de comandos e desvios nas funções do recorte e 95,8% de escore de mutação. Os 8 mutantes vivos são equivalentes, então 100% dos não equivalentes morreram. No gráfico, a cobertura sobe na etapa estrutural e o escore sobe na mutação.</a:t>
+              <a:t>Números (30 s): a suíte final tem 25 casos, 100% de comandos e desvios nas funções do recorte e 95,0% de escore de mutação. Os 7 mutantes vivos são equivalentes, então 100% dos não equivalentes morreram. No gráfico, a cobertura sobe na etapa estrutural e o escore sobe na mutação.</a:t>
             </a:r>
           </a:p>
           <a:p/>
@@ -959,7 +959,7 @@
           <a:p/>
           <a:p>
             <a:r>
-              <a:t>Lições (40 s): limites acham defeitos que valores típicos não acham; cobertura mede o que executou, não o que foi verificado (o original tinha 100% dos comandos com 31 testes falhando); a mutação avaliou a própria suíte e mostrou fragilidades mesmo com 100% dos desvios; e é preciso corrigir antes de mutar.</a:t>
+              <a:t>Lições (40 s): limites acham defeitos que valores típicos não acham; cobertura mede o que executou, não o que foi verificado (o original tinha 100% dos comandos com 10 testes falhando); a mutação avaliou a própria suíte e mostrou fragilidades mesmo com 100% dos desvios; e é preciso corrigir antes de mutar.</a:t>
             </a:r>
           </a:p>
         </p:txBody>
@@ -4402,7 +4402,7 @@
                 </a:solidFill>
                 <a:latin typeface="Segoe UI"/>
               </a:rPr>
-              <a:t>42 classes</a:t>
+              <a:t>22 classes</a:t>
             </a:r>
             <a:r>
               <a:rPr sz="1050" b="0">
@@ -4411,7 +4411,7 @@
                 </a:solidFill>
                 <a:latin typeface="Segoe UI"/>
               </a:rPr>
-              <a:t> (23 válidas, 19 inválidas)</a:t>
+              <a:t> (11 válidas, 11 inválidas)</a:t>
             </a:r>
           </a:p>
           <a:p>
@@ -4427,7 +4427,7 @@
                 </a:solidFill>
                 <a:latin typeface="Segoe UI"/>
               </a:rPr>
-              <a:t>Valor limite: abaixo / no limite / acima</a:t>
+              <a:t>1 caso por classe inválida, limites embutidos</a:t>
             </a:r>
           </a:p>
           <a:p>
@@ -4443,7 +4443,7 @@
                 </a:solidFill>
                 <a:latin typeface="Segoe UI"/>
               </a:rPr>
-              <a:t>50 casos</a:t>
+              <a:t>15 casos</a:t>
             </a:r>
             <a:r>
               <a:rPr sz="1050" b="0">
@@ -4468,7 +4468,7 @@
                 </a:solidFill>
                 <a:latin typeface="Segoe UI"/>
               </a:rPr>
-              <a:t>28 falham</a:t>
+              <a:t>9 falham</a:t>
             </a:r>
             <a:r>
               <a:rPr sz="1050" b="0">
@@ -4477,7 +4477,7 @@
                 </a:solidFill>
                 <a:latin typeface="Segoe UI"/>
               </a:rPr>
-              <a:t> → 12 defeitos</a:t>
+              <a:t> → 9 defeitos</a:t>
             </a:r>
           </a:p>
         </p:txBody>
@@ -4643,7 +4643,7 @@
                 </a:solidFill>
                 <a:latin typeface="Segoe UI"/>
               </a:rPr>
-              <a:t>+7 casos</a:t>
+              <a:t>+4 casos</a:t>
             </a:r>
             <a:r>
               <a:rPr sz="1050" b="0">
@@ -4668,7 +4668,7 @@
                 </a:solidFill>
                 <a:latin typeface="Segoe UI"/>
               </a:rPr>
-              <a:t>+3 defeitos</a:t>
+              <a:t>+1 defeito</a:t>
             </a:r>
             <a:r>
               <a:rPr sz="1050" b="0">
@@ -4677,7 +4677,7 @@
                 </a:solidFill>
                 <a:latin typeface="Segoe UI"/>
               </a:rPr>
-              <a:t> só visíveis no código</a:t>
+              <a:t> só visível no código</a:t>
             </a:r>
           </a:p>
           <a:p>
@@ -4693,7 +4693,7 @@
                 </a:solidFill>
                 <a:latin typeface="Segoe UI"/>
               </a:rPr>
-              <a:t>98,0%</a:t>
+              <a:t>97,1%</a:t>
             </a:r>
             <a:r>
               <a:rPr sz="1050" b="0">
@@ -4834,7 +4834,7 @@
                 </a:solidFill>
                 <a:latin typeface="Segoe UI"/>
               </a:rPr>
-              <a:t>15 defeitos</a:t>
+              <a:t>10 defeitos</a:t>
             </a:r>
             <a:r>
               <a:rPr sz="1050" b="0">
@@ -4843,7 +4843,7 @@
                 </a:solidFill>
                 <a:latin typeface="Segoe UI"/>
               </a:rPr>
-              <a:t> corrigidos (+4 do cancelamento)</a:t>
+              <a:t> corrigidos (+9 dos secundários)</a:t>
             </a:r>
           </a:p>
           <a:p>
@@ -4875,7 +4875,7 @@
                 </a:solidFill>
                 <a:latin typeface="Segoe UI"/>
               </a:rPr>
-              <a:t>57/57</a:t>
+              <a:t>19/19</a:t>
             </a:r>
             <a:r>
               <a:rPr sz="1050" b="0">
@@ -4982,7 +4982,7 @@
                 </a:solidFill>
                 <a:latin typeface="Segoe UI"/>
               </a:rPr>
-              <a:t>Cosmic Ray · 189 mutantes</a:t>
+              <a:t>Cosmic Ray · 141 mutantes</a:t>
             </a:r>
           </a:p>
         </p:txBody>
@@ -5050,7 +5050,7 @@
                 </a:solidFill>
                 <a:latin typeface="Segoe UI"/>
               </a:rPr>
-              <a:t>94,2%</a:t>
+              <a:t>90,1%</a:t>
             </a:r>
             <a:r>
               <a:rPr sz="1050" b="0">
@@ -5059,7 +5059,7 @@
                 </a:solidFill>
                 <a:latin typeface="Segoe UI"/>
               </a:rPr>
-              <a:t> (178/189)</a:t>
+              <a:t> (127/141)</a:t>
             </a:r>
           </a:p>
           <a:p>
@@ -5075,7 +5075,7 @@
                 </a:solidFill>
                 <a:latin typeface="Segoe UI"/>
               </a:rPr>
-              <a:t>11 vivos: </a:t>
+              <a:t>14 vivos: </a:t>
             </a:r>
             <a:r>
               <a:rPr sz="1050" b="1">
@@ -5084,7 +5084,7 @@
                 </a:solidFill>
                 <a:latin typeface="Segoe UI"/>
               </a:rPr>
-              <a:t>3 matáveis</a:t>
+              <a:t>7 matáveis</a:t>
             </a:r>
             <a:r>
               <a:rPr sz="1050" b="0">
@@ -5093,7 +5093,7 @@
                 </a:solidFill>
                 <a:latin typeface="Segoe UI"/>
               </a:rPr>
-              <a:t>, 8 equivalentes</a:t>
+              <a:t>, 7 equivalentes</a:t>
             </a:r>
           </a:p>
           <a:p>
@@ -5109,7 +5109,7 @@
                 </a:solidFill>
                 <a:latin typeface="Segoe UI"/>
               </a:rPr>
-              <a:t>+3 casos</a:t>
+              <a:t>+6 casos</a:t>
             </a:r>
             <a:r>
               <a:rPr sz="1050" b="0">
@@ -5143,7 +5143,7 @@
                 </a:solidFill>
                 <a:latin typeface="Segoe UI"/>
               </a:rPr>
-              <a:t>95,8%</a:t>
+              <a:t>95,0%</a:t>
             </a:r>
             <a:r>
               <a:rPr sz="1050" b="0">
@@ -5858,7 +5858,7 @@
                 </a:solidFill>
                 <a:latin typeface="Segoe UI"/>
               </a:rPr>
-              <a:t>60 casos · 15 defeitos nos 3 requisitos, todos corrigidos · 100% dos desvios · 95,8% de escore de mutação</a:t>
+              <a:t>25 casos · 10 defeitos nos 3 requisitos, todos corrigidos · 100% dos desvios · 95,0% de escore de mutação</a:t>
             </a:r>
           </a:p>
         </p:txBody>
@@ -5972,7 +5972,7 @@
                 </a:solidFill>
                 <a:latin typeface="Segoe UI"/>
               </a:rPr>
-              <a:t>60</a:t>
+              <a:t>25</a:t>
             </a:r>
           </a:p>
           <a:p>
@@ -6047,7 +6047,7 @@
                 </a:solidFill>
                 <a:latin typeface="Segoe UI"/>
               </a:rPr>
-              <a:t>15</a:t>
+              <a:t>10</a:t>
             </a:r>
           </a:p>
           <a:p>
@@ -6197,7 +6197,7 @@
                 </a:solidFill>
                 <a:latin typeface="Segoe UI"/>
               </a:rPr>
-              <a:t>95,8%</a:t>
+              <a:t>95,0%</a:t>
             </a:r>
           </a:p>
           <a:p>
@@ -6603,7 +6603,7 @@
                 </a:solidFill>
                 <a:latin typeface="Segoe UI"/>
               </a:rPr>
-              <a:t>• Filtro em </a:t>
+              <a:t>• </a:t>
             </a:r>
             <a:r>
               <a:rPr sz="950" b="1">
@@ -6612,7 +6612,7 @@
                 </a:solidFill>
                 <a:latin typeface="Segoe UI"/>
               </a:rPr>
-              <a:t>variável global</a:t>
+              <a:t>Quarto inexistente ou repetido</a:t>
             </a:r>
             <a:r>
               <a:rPr sz="950" b="0">
@@ -6621,7 +6621,7 @@
                 </a:solidFill>
                 <a:latin typeface="Segoe UI"/>
               </a:rPr>
-              <a:t> vaza entre sessões</a:t>
+              <a:t> aceito na reserva</a:t>
             </a:r>
           </a:p>
           <a:p>
@@ -6855,7 +6855,7 @@
                 </a:solidFill>
                 <a:latin typeface="Segoe UI"/>
               </a:rPr>
-              <a:t>: a técnica funcional achou 12 dos 15 defeitos</a:t>
+              <a:t>: 15 casos funcionais acharam 9 dos 10 defeitos</a:t>
             </a:r>
           </a:p>
           <a:p>
@@ -6889,7 +6889,7 @@
                 </a:solidFill>
                 <a:latin typeface="Segoe UI"/>
               </a:rPr>
-              <a:t>: 100% dos comandos no original com 31 testes falhando</a:t>
+              <a:t>: 100% dos comandos no original com 10 testes falhando</a:t>
             </a:r>
           </a:p>
           <a:p>
@@ -6923,7 +6923,7 @@
                 </a:solidFill>
                 <a:latin typeface="Segoe UI"/>
               </a:rPr>
-              <a:t>: com 100% dos desvios ainda havia 3 mutantes vivos</a:t>
+              <a:t>: com 100% dos desvios ainda havia 7 mutantes não equivalentes vivos</a:t>
             </a:r>
           </a:p>
           <a:p>

</xml_diff>

<commit_message>
Mesmos 15 casos nas três etapas, com datas reais
A etapa estrutural deixa de criar casos: reaproveita 5 funcionais (CT-001,
CT-005, CT-009, CT-012, CT-013) para percorrer os grafos e amplia 3 deles
(CT-001, CT-005 e CT-012) com o cenário que faltava; o DEF-15 continua
revelado pela ampliação do CT-012. A mutação roda os 15 casos e mata os 7
sobreviventes não equivalentes ampliando CT-002, CT-003, CT-012 e CT-015.
Nomes dos casos reescritos; datas fixas (março de 2030) no lugar de D+n,
exceto nos casos de hoje e ontem. Quarto 103 da base passa a ser o 301.

Resultados: funcional 15 casos (9 defeitos, 95,2%/85,3%); estrutural 15 casos
(18 testes; 100%/97,1%; DEF-15); corrigido 15/15 (100%/100%); mutação
127/141 -> 134/141 (7 equivalentes). Evidências, relatório e slides regenerados.
</commit_message>
<xml_diff>
--- a/docs/apresentacao-2-slides.pptx
+++ b/docs/apresentacao-2-slides.pptx
@@ -167,13 +167,13 @@
                   <c:v>Funcional (15)</c:v>
                 </c:pt>
                 <c:pt idx="1">
-                  <c:v>Estrutural (19)</c:v>
+                  <c:v>Estrutural (15)</c:v>
                 </c:pt>
                 <c:pt idx="2">
-                  <c:v>Correção (19)</c:v>
+                  <c:v>Correção (15)</c:v>
                 </c:pt>
                 <c:pt idx="3">
-                  <c:v>Mutação (25)</c:v>
+                  <c:v>Mutação (15)</c:v>
                 </c:pt>
               </c:strCache>
             </c:strRef>
@@ -250,13 +250,13 @@
                   <c:v>Funcional (15)</c:v>
                 </c:pt>
                 <c:pt idx="1">
-                  <c:v>Estrutural (19)</c:v>
+                  <c:v>Estrutural (15)</c:v>
                 </c:pt>
                 <c:pt idx="2">
-                  <c:v>Correção (19)</c:v>
+                  <c:v>Correção (15)</c:v>
                 </c:pt>
                 <c:pt idx="3">
-                  <c:v>Mutação (25)</c:v>
+                  <c:v>Mutação (15)</c:v>
                 </c:pt>
               </c:strCache>
             </c:strRef>
@@ -333,13 +333,13 @@
                   <c:v>Funcional (15)</c:v>
                 </c:pt>
                 <c:pt idx="1">
-                  <c:v>Estrutural (19)</c:v>
+                  <c:v>Estrutural (15)</c:v>
                 </c:pt>
                 <c:pt idx="2">
-                  <c:v>Correção (19)</c:v>
+                  <c:v>Correção (15)</c:v>
                 </c:pt>
                 <c:pt idx="3">
-                  <c:v>Mutação (25)</c:v>
+                  <c:v>Mutação (15)</c:v>
                 </c:pt>
               </c:strCache>
             </c:strRef>
@@ -847,7 +847,7 @@
           <a:p/>
           <a:p>
             <a:r>
-              <a:t>Estrutural (40 s): medi com coverage.py --branch e defini a meta de 100% dos desvios viáveis. Os ramos que faltavam levaram a 4 casos novos e, lendo o laço triplo, a um defeito que a especificação não sugeria: um produto cartesiano entre reservas e vínculos, mascarado pela tautologia.</a:t>
+              <a:t>Estrutural (40 s): medi com coverage.py --branch e defini a meta de 100% dos desvios viáveis. Os ramos que faltavam foram cobertos sem criar casos: reaproveitei 5 funcionais para percorrer os grafos e ampliei 3 deles. Lendo o laço triplo, achei um defeito que a especificação não sugeria: um produto cartesiano entre reservas e vínculos, mascarado pela tautologia.</a:t>
             </a:r>
           </a:p>
           <a:p/>
@@ -859,7 +859,7 @@
           <a:p/>
           <a:p>
             <a:r>
-              <a:t>Mutação (40 s): Cosmic Ray sobre todos os 141 mutantes das funções dos três requisitos. Dos 14 vivos, 7 eram matáveis e ganharam casos; os 7 restantes são equivalentes e estão justificados no relatório.</a:t>
+              <a:t>Mutação (40 s): Cosmic Ray sobre todos os 141 mutantes das funções dos três requisitos. Dos 14 vivos, 7 eram matáveis e foram mortos ampliando 4 dos mesmos 15 casos; os 7 restantes são equivalentes e estão justificados no relatório.</a:t>
             </a:r>
           </a:p>
           <a:p/>
@@ -935,7 +935,7 @@
           <a:lstStyle/>
           <a:p>
             <a:r>
-              <a:t>Números (30 s): a suíte final tem 25 casos, 100% de comandos e desvios nas funções do recorte e 95,0% de escore de mutação. Os 7 mutantes vivos são equivalentes, então 100% dos não equivalentes morreram. No gráfico, a cobertura sobe na etapa estrutural e o escore sobe na mutação.</a:t>
+              <a:t>Números (30 s): os mesmos 15 casos atravessam as três etapas (ampliados quando faltou um cenário), com 100% de comandos e desvios nas funções do recorte e 95,0% de escore de mutação. Os 7 mutantes vivos são equivalentes, então 100% dos não equivalentes morreram. No gráfico, a cobertura sobe na etapa estrutural e o escore sobe na mutação.</a:t>
             </a:r>
           </a:p>
           <a:p/>
@@ -4643,7 +4643,7 @@
                 </a:solidFill>
                 <a:latin typeface="Segoe UI"/>
               </a:rPr>
-              <a:t>+4 casos</a:t>
+              <a:t>5 casos reaproveitados</a:t>
             </a:r>
             <a:r>
               <a:rPr sz="1050" b="0">
@@ -4652,7 +4652,7 @@
                 </a:solidFill>
                 <a:latin typeface="Segoe UI"/>
               </a:rPr>
-              <a:t> guiados pelas lacunas</a:t>
+              <a:t>; 3 ampliados nas lacunas</a:t>
             </a:r>
           </a:p>
           <a:p>
@@ -4875,7 +4875,7 @@
                 </a:solidFill>
                 <a:latin typeface="Segoe UI"/>
               </a:rPr>
-              <a:t>19/19</a:t>
+              <a:t>15/15</a:t>
             </a:r>
             <a:r>
               <a:rPr sz="1050" b="0">
@@ -4884,7 +4884,7 @@
                 </a:solidFill>
                 <a:latin typeface="Segoe UI"/>
               </a:rPr>
-              <a:t> passam, sem skip</a:t>
+              <a:t> casos passam, sem skip</a:t>
             </a:r>
           </a:p>
           <a:p>
@@ -5109,7 +5109,7 @@
                 </a:solidFill>
                 <a:latin typeface="Segoe UI"/>
               </a:rPr>
-              <a:t>+6 casos</a:t>
+              <a:t>4 casos ampliados</a:t>
             </a:r>
             <a:r>
               <a:rPr sz="1050" b="0">
@@ -5118,7 +5118,7 @@
                 </a:solidFill>
                 <a:latin typeface="Segoe UI"/>
               </a:rPr>
-              <a:t> para os matáveis</a:t>
+              <a:t>, nenhum novo</a:t>
             </a:r>
           </a:p>
           <a:p>
@@ -5858,7 +5858,7 @@
                 </a:solidFill>
                 <a:latin typeface="Segoe UI"/>
               </a:rPr>
-              <a:t>25 casos · 10 defeitos nos 3 requisitos, todos corrigidos · 100% dos desvios · 95,0% de escore de mutação</a:t>
+              <a:t>os mesmos 15 casos nas 3 etapas · 10 defeitos, todos corrigidos · 100% dos desvios · 95,0% de escore de mutação</a:t>
             </a:r>
           </a:p>
         </p:txBody>
@@ -5972,7 +5972,7 @@
                 </a:solidFill>
                 <a:latin typeface="Segoe UI"/>
               </a:rPr>
-              <a:t>25</a:t>
+              <a:t>15</a:t>
             </a:r>
           </a:p>
           <a:p>

</xml_diff>

<commit_message>
Escore de mutação pela fórmula da disciplina: mortos ÷ (gerados − equivalentes)
Relatório, slides e README das evidências passam a usar 127 ÷ 134 = 94,8% na
rodada inicial e 134 ÷ 134 = 100,0% na final, com o escore bruto (90,1% e
95,0%) entre parênteses.
</commit_message>
<xml_diff>
--- a/docs/apresentacao-2-slides.pptx
+++ b/docs/apresentacao-2-slides.pptx
@@ -351,10 +351,10 @@
                 <c:formatCode>General</c:formatCode>
                 <c:ptCount val="4"/>
                 <c:pt idx="2">
-                  <c:v>0.9009999999999999</c:v>
+                  <c:v>0.9477611940298507</c:v>
                 </c:pt>
                 <c:pt idx="3">
-                  <c:v>0.95</c:v>
+                  <c:v>1.0</c:v>
                 </c:pt>
               </c:numCache>
             </c:numRef>
@@ -859,7 +859,7 @@
           <a:p/>
           <a:p>
             <a:r>
-              <a:t>Mutação (40 s): Cosmic Ray sobre todos os 141 mutantes das funções dos três requisitos. Dos 14 vivos, 7 eram matáveis e foram mortos ampliando 4 dos mesmos 15 casos; os 7 restantes são equivalentes e estão justificados no relatório.</a:t>
+              <a:t>Mutação (40 s): Cosmic Ray sobre todos os 141 mutantes das funções dos três requisitos. Dos 14 vivos, 7 eram matáveis e foram mortos ampliando 4 dos mesmos 15 casos; os 7 restantes são equivalentes e estão justificados no relatório. Pela fórmula da disciplina, que tira os equivalentes do denominador, o escore foi de 94,8% para 100,0% (sem descontar: 90,1% e 95,0%).</a:t>
             </a:r>
           </a:p>
           <a:p/>
@@ -935,7 +935,7 @@
           <a:lstStyle/>
           <a:p>
             <a:r>
-              <a:t>Números (30 s): os mesmos 15 casos atravessam as três etapas (ampliados quando faltou um cenário), com 100% de comandos e desvios nas funções do recorte e 95,0% de escore de mutação. Os 7 mutantes vivos são equivalentes, então 100% dos não equivalentes morreram. No gráfico, a cobertura sobe na etapa estrutural e o escore sobe na mutação.</a:t>
+              <a:t>Números (30 s): os mesmos 15 casos atravessam as três etapas (ampliados quando faltou um cenário), com 100% de comandos e desvios nas funções do recorte e 100,0% de escore de mutação: 134 mortos ÷ (141 gerados − 7 equivalentes). Os 7 mutantes vivos são equivalentes, por isso saem do denominador (sem descontar, o escore seria 95,0%). No gráfico, a cobertura sobe na etapa estrutural e o escore sobe na mutação.</a:t>
             </a:r>
           </a:p>
           <a:p/>
@@ -5041,25 +5041,7 @@
                 </a:solidFill>
                 <a:latin typeface="Segoe UI"/>
               </a:rPr>
-              <a:t>Inicial: </a:t>
-            </a:r>
-            <a:r>
-              <a:rPr sz="1050" b="1">
-                <a:solidFill>
-                  <a:srgbClr val="0B1F3A"/>
-                </a:solidFill>
-                <a:latin typeface="Segoe UI"/>
-              </a:rPr>
-              <a:t>90,1%</a:t>
-            </a:r>
-            <a:r>
-              <a:rPr sz="1050" b="0">
-                <a:solidFill>
-                  <a:srgbClr val="0B1F3A"/>
-                </a:solidFill>
-                <a:latin typeface="Segoe UI"/>
-              </a:rPr>
-              <a:t> (127/141)</a:t>
+              <a:t>Escore = mortos ÷ (gerados − 7 equivalentes)</a:t>
             </a:r>
           </a:p>
           <a:p>
@@ -5075,7 +5057,7 @@
                 </a:solidFill>
                 <a:latin typeface="Segoe UI"/>
               </a:rPr>
-              <a:t>14 vivos: </a:t>
+              <a:t>Inicial: </a:t>
             </a:r>
             <a:r>
               <a:rPr sz="1050" b="1">
@@ -5084,7 +5066,7 @@
                 </a:solidFill>
                 <a:latin typeface="Segoe UI"/>
               </a:rPr>
-              <a:t>7 matáveis</a:t>
+              <a:t>94,8%</a:t>
             </a:r>
             <a:r>
               <a:rPr sz="1050" b="0">
@@ -5093,7 +5075,7 @@
                 </a:solidFill>
                 <a:latin typeface="Segoe UI"/>
               </a:rPr>
-              <a:t>, 7 equivalentes</a:t>
+              <a:t> (127/134)</a:t>
             </a:r>
           </a:p>
           <a:p>
@@ -5103,22 +5085,40 @@
               </a:spcAft>
             </a:pPr>
             <a:r>
+              <a:rPr sz="1050" b="0">
+                <a:solidFill>
+                  <a:srgbClr val="0B1F3A"/>
+                </a:solidFill>
+                <a:latin typeface="Segoe UI"/>
+              </a:rPr>
+              <a:t>14 vivos: </a:t>
+            </a:r>
+            <a:r>
               <a:rPr sz="1050" b="1">
                 <a:solidFill>
                   <a:srgbClr val="0B1F3A"/>
                 </a:solidFill>
                 <a:latin typeface="Segoe UI"/>
               </a:rPr>
+              <a:t>7 matáveis</a:t>
+            </a:r>
+            <a:r>
+              <a:rPr sz="1050" b="0">
+                <a:solidFill>
+                  <a:srgbClr val="0B1F3A"/>
+                </a:solidFill>
+                <a:latin typeface="Segoe UI"/>
+              </a:rPr>
+              <a:t>; </a:t>
+            </a:r>
+            <a:r>
+              <a:rPr sz="1050" b="1">
+                <a:solidFill>
+                  <a:srgbClr val="0B1F3A"/>
+                </a:solidFill>
+                <a:latin typeface="Segoe UI"/>
+              </a:rPr>
               <a:t>4 casos ampliados</a:t>
-            </a:r>
-            <a:r>
-              <a:rPr sz="1050" b="0">
-                <a:solidFill>
-                  <a:srgbClr val="0B1F3A"/>
-                </a:solidFill>
-                <a:latin typeface="Segoe UI"/>
-              </a:rPr>
-              <a:t>, nenhum novo</a:t>
             </a:r>
           </a:p>
           <a:p>
@@ -5143,7 +5143,7 @@
                 </a:solidFill>
                 <a:latin typeface="Segoe UI"/>
               </a:rPr>
-              <a:t>95,0%</a:t>
+              <a:t>100,0%</a:t>
             </a:r>
             <a:r>
               <a:rPr sz="1050" b="0">
@@ -5152,7 +5152,7 @@
                 </a:solidFill>
                 <a:latin typeface="Segoe UI"/>
               </a:rPr>
-              <a:t> · 100% dos não equivalentes</a:t>
+              <a:t> (134/134)</a:t>
             </a:r>
           </a:p>
         </p:txBody>
@@ -5858,7 +5858,7 @@
                 </a:solidFill>
                 <a:latin typeface="Segoe UI"/>
               </a:rPr>
-              <a:t>os mesmos 15 casos nas 3 etapas · 10 defeitos, todos corrigidos · 100% dos desvios · 95,0% de escore de mutação</a:t>
+              <a:t>os mesmos 15 casos nas 3 etapas · 10 defeitos, todos corrigidos · 100% dos desvios · 100,0% de escore de mutação</a:t>
             </a:r>
           </a:p>
         </p:txBody>
@@ -6197,7 +6197,7 @@
                 </a:solidFill>
                 <a:latin typeface="Segoe UI"/>
               </a:rPr>
-              <a:t>95,0%</a:t>
+              <a:t>100,0%</a:t>
             </a:r>
           </a:p>
           <a:p>
@@ -6213,7 +6213,7 @@
                 </a:solidFill>
                 <a:latin typeface="Segoe UI"/>
               </a:rPr>
-              <a:t>escore de mutação</a:t>
+              <a:t>escore de mutação (134 ÷ 134)</a:t>
             </a:r>
           </a:p>
         </p:txBody>

</xml_diff>